<commit_message>
style(slides): improve clarity, increase typography scale, and eliminate text collisions for presentation
</commit_message>
<xml_diff>
--- a/AIA_Illinois_Midpoint_Checkpoint_Raghav_Agarwal.pptx
+++ b/AIA_Illinois_Midpoint_Checkpoint_Raghav_Agarwal.pptx
@@ -4522,11 +4522,11 @@
                 <a:spcPct val="115000"/>
               </a:lnSpc>
               <a:spcAft>
-                <a:spcPts val="300"/>
+                <a:spcPts val="400"/>
               </a:spcAft>
             </a:pPr>
             <a:r>
-              <a:rPr sz="1200" b="1">
+              <a:rPr sz="1300" b="1">
                 <a:solidFill>
                   <a:srgbClr val="FF5F05"/>
                 </a:solidFill>
@@ -4859,7 +4859,7 @@
               </a:defRPr>
             </a:pPr>
             <a:r>
-              <a:rPr sz="975">
+              <a:rPr sz="1000">
                 <a:solidFill>
                   <a:srgbClr val="C6C7C6"/>
                 </a:solidFill>
@@ -5241,7 +5241,7 @@
         </p:nvSpPr>
         <p:spPr>
           <a:xfrm xmlns:a="http://schemas.openxmlformats.org/drawingml/2006/main">
-            <a:off x="609600" y="4619625"/>
+            <a:off x="609600" y="4800600"/>
             <a:ext cx="8572500" cy="857250"/>
           </a:xfrm>
           <a:prstGeom xmlns:a="http://schemas.openxmlformats.org/drawingml/2006/main" prst="rect">
@@ -5362,11 +5362,11 @@
                 <a:spcPct val="115000"/>
               </a:lnSpc>
               <a:spcAft>
-                <a:spcPts val="400"/>
+                <a:spcPts val="500"/>
               </a:spcAft>
             </a:pPr>
             <a:r>
-              <a:rPr sz="1700" b="0">
+              <a:rPr sz="1750" b="0">
                 <a:solidFill>
                   <a:srgbClr val="FFFFFF"/>
                 </a:solidFill>
@@ -5381,11 +5381,11 @@
                 <a:spcPct val="115000"/>
               </a:lnSpc>
               <a:spcAft>
-                <a:spcPts val="400"/>
+                <a:spcPts val="500"/>
               </a:spcAft>
             </a:pPr>
             <a:r>
-              <a:rPr sz="1700" b="0">
+              <a:rPr sz="1750" b="0">
                 <a:solidFill>
                   <a:srgbClr val="FFFFFF"/>
                 </a:solidFill>
@@ -6036,9 +6036,9 @@
               </a:defRPr>
             </a:pPr>
             <a:r>
-              <a:rPr sz="975">
-                <a:solidFill>
-                  <a:srgbClr val="67758A"/>
+              <a:rPr sz="1000">
+                <a:solidFill>
+                  <a:srgbClr val="475569"/>
                 </a:solidFill>
                 <a:latin typeface="Courier New"/>
               </a:rPr>
@@ -6236,14 +6236,14 @@
                     <a:p>
                       <a:pPr>
                         <a:lnSpc>
-                          <a:spcPct val="110000"/>
+                          <a:spcPct val="115000"/>
                         </a:lnSpc>
                         <a:spcAft>
-                          <a:spcPts val="200"/>
+                          <a:spcPts val="300"/>
                         </a:spcAft>
                       </a:pPr>
                       <a:r>
-                        <a:rPr sz="1150" b="1">
+                        <a:rPr sz="1300" b="1">
                           <a:solidFill>
                             <a:srgbClr val="FFFFFF"/>
                           </a:solidFill>
@@ -6290,14 +6290,14 @@
                     <a:p>
                       <a:pPr>
                         <a:lnSpc>
-                          <a:spcPct val="110000"/>
+                          <a:spcPct val="115000"/>
                         </a:lnSpc>
                         <a:spcAft>
-                          <a:spcPts val="200"/>
+                          <a:spcPts val="300"/>
                         </a:spcAft>
                       </a:pPr>
                       <a:r>
-                        <a:rPr sz="1150" b="1">
+                        <a:rPr sz="1300" b="1">
                           <a:solidFill>
                             <a:srgbClr val="FFFFFF"/>
                           </a:solidFill>
@@ -6338,14 +6338,14 @@
                     <a:p>
                       <a:pPr>
                         <a:lnSpc>
-                          <a:spcPct val="110000"/>
+                          <a:spcPct val="115000"/>
                         </a:lnSpc>
                         <a:spcAft>
-                          <a:spcPts val="200"/>
+                          <a:spcPts val="300"/>
                         </a:spcAft>
                       </a:pPr>
                       <a:r>
-                        <a:rPr sz="1150" b="1">
+                        <a:rPr sz="1300" b="1">
                           <a:solidFill>
                             <a:srgbClr val="FFFFFF"/>
                           </a:solidFill>
@@ -6388,14 +6388,14 @@
                     <a:p>
                       <a:pPr>
                         <a:lnSpc>
-                          <a:spcPct val="110000"/>
+                          <a:spcPct val="115000"/>
                         </a:lnSpc>
                         <a:spcAft>
-                          <a:spcPts val="200"/>
+                          <a:spcPts val="300"/>
                         </a:spcAft>
                       </a:pPr>
                       <a:r>
-                        <a:rPr sz="1019" b="0">
+                        <a:rPr sz="1200" b="0">
                           <a:solidFill>
                             <a:srgbClr val="13294B"/>
                           </a:solidFill>
@@ -6436,14 +6436,14 @@
                     <a:p>
                       <a:pPr>
                         <a:lnSpc>
-                          <a:spcPct val="110000"/>
+                          <a:spcPct val="115000"/>
                         </a:lnSpc>
                         <a:spcAft>
-                          <a:spcPts val="200"/>
+                          <a:spcPts val="300"/>
                         </a:spcAft>
                       </a:pPr>
                       <a:r>
-                        <a:rPr sz="1019" b="0">
+                        <a:rPr sz="1200" b="0">
                           <a:solidFill>
                             <a:srgbClr val="13294B"/>
                           </a:solidFill>
@@ -6478,20 +6478,20 @@
                     <a:p>
                       <a:pPr>
                         <a:lnSpc>
-                          <a:spcPct val="110000"/>
+                          <a:spcPct val="115000"/>
                         </a:lnSpc>
                         <a:spcAft>
-                          <a:spcPts val="200"/>
+                          <a:spcPts val="300"/>
                         </a:spcAft>
                       </a:pPr>
                       <a:r>
-                        <a:rPr sz="1019" b="0">
+                        <a:rPr sz="1200" b="0">
                           <a:solidFill>
                             <a:srgbClr val="13294B"/>
                           </a:solidFill>
                           <a:latin typeface="Arial"/>
                         </a:rPr>
-                        <a:t>Clamping/steering along probe vector proves bidirectional causal control over sleeper trigger firing during rollouts.</a:t>
+                        <a:t>Clamping probe vector at Layers 14–19 proves bidirectional causal control over sleeper trigger firing during rollouts.</a:t>
                       </a:r>
                     </a:p>
                   </a:txBody>
@@ -6522,14 +6522,14 @@
                     <a:p>
                       <a:pPr>
                         <a:lnSpc>
-                          <a:spcPct val="110000"/>
+                          <a:spcPct val="115000"/>
                         </a:lnSpc>
                         <a:spcAft>
-                          <a:spcPts val="200"/>
+                          <a:spcPts val="300"/>
                         </a:spcAft>
                       </a:pPr>
                       <a:r>
-                        <a:rPr sz="1019" b="0">
+                        <a:rPr sz="1200" b="0">
                           <a:solidFill>
                             <a:srgbClr val="13294B"/>
                           </a:solidFill>
@@ -6570,14 +6570,14 @@
                     <a:p>
                       <a:pPr>
                         <a:lnSpc>
-                          <a:spcPct val="110000"/>
+                          <a:spcPct val="115000"/>
                         </a:lnSpc>
                         <a:spcAft>
-                          <a:spcPts val="200"/>
+                          <a:spcPts val="300"/>
                         </a:spcAft>
                       </a:pPr>
                       <a:r>
-                        <a:rPr sz="1019" b="0">
+                        <a:rPr sz="1200" b="0">
                           <a:solidFill>
                             <a:srgbClr val="13294B"/>
                           </a:solidFill>
@@ -6612,20 +6612,20 @@
                     <a:p>
                       <a:pPr>
                         <a:lnSpc>
-                          <a:spcPct val="110000"/>
+                          <a:spcPct val="115000"/>
                         </a:lnSpc>
                         <a:spcAft>
-                          <a:spcPts val="200"/>
+                          <a:spcPts val="300"/>
                         </a:spcAft>
                       </a:pPr>
                       <a:r>
-                        <a:rPr sz="1019" b="0">
+                        <a:rPr sz="1200" b="0">
                           <a:solidFill>
                             <a:srgbClr val="13294B"/>
                           </a:solidFill>
                           <a:latin typeface="Arial"/>
                         </a:rPr>
-                        <a:t>Replicate probe extraction on Llama-3-70B and evaluate against full Realism Ladder (L0–L4 disguise levels).</a:t>
+                        <a:t>Replicate probe extraction on Llama-3-70B; benchmark against full Realism Ladder (L0–L4 camouflage).</a:t>
                       </a:r>
                     </a:p>
                   </a:txBody>
@@ -6656,14 +6656,14 @@
                     <a:p>
                       <a:pPr>
                         <a:lnSpc>
-                          <a:spcPct val="110000"/>
+                          <a:spcPct val="115000"/>
                         </a:lnSpc>
                         <a:spcAft>
-                          <a:spcPts val="200"/>
+                          <a:spcPts val="300"/>
                         </a:spcAft>
                       </a:pPr>
                       <a:r>
-                        <a:rPr sz="1019" b="0">
+                        <a:rPr sz="1200" b="0">
                           <a:solidFill>
                             <a:srgbClr val="13294B"/>
                           </a:solidFill>
@@ -6704,14 +6704,14 @@
                     <a:p>
                       <a:pPr>
                         <a:lnSpc>
-                          <a:spcPct val="110000"/>
+                          <a:spcPct val="115000"/>
                         </a:lnSpc>
                         <a:spcAft>
-                          <a:spcPts val="200"/>
+                          <a:spcPts val="300"/>
                         </a:spcAft>
                       </a:pPr>
                       <a:r>
-                        <a:rPr sz="1019" b="0">
+                        <a:rPr sz="1200" b="0">
                           <a:solidFill>
                             <a:srgbClr val="13294B"/>
                           </a:solidFill>
@@ -6746,20 +6746,20 @@
                     <a:p>
                       <a:pPr>
                         <a:lnSpc>
-                          <a:spcPct val="110000"/>
+                          <a:spcPct val="115000"/>
                         </a:lnSpc>
                         <a:spcAft>
-                          <a:spcPts val="200"/>
+                          <a:spcPts val="300"/>
                         </a:spcAft>
                       </a:pPr>
                       <a:r>
-                        <a:rPr sz="1019" b="0">
+                        <a:rPr sz="1200" b="0">
                           <a:solidFill>
                             <a:srgbClr val="13294B"/>
                           </a:solidFill>
                           <a:latin typeface="Arial"/>
                         </a:rPr>
-                        <a:t>Release modular sleeper detection library, reproducible benchmark artifacts, and submit fellowship final report / preprint.</a:t>
+                        <a:t>Release modular sleeper detection middleware on GitHub; submit fellowship final report / preprint.</a:t>
                       </a:r>
                     </a:p>
                   </a:txBody>
@@ -6923,17 +6923,17 @@
                 <a:spcPct val="115000"/>
               </a:lnSpc>
               <a:spcAft>
-                <a:spcPts val="200"/>
+                <a:spcPts val="300"/>
               </a:spcAft>
             </a:pPr>
             <a:r>
-              <a:rPr sz="1400" b="0">
+              <a:rPr sz="1550" b="1">
                 <a:solidFill>
                   <a:srgbClr val="13294B"/>
                 </a:solidFill>
                 <a:latin typeface="Arial"/>
               </a:rPr>
-              <a:t>DELIVERABLES  /  Preprint for ICLR/SafeAI Workshop  ·  Open-source detection toolkit on GitHub  ·  Interactive demo</a:t>
+              <a:t>DELIVERABLES  /  Fellowship preprint  ·  Open-source detection toolkit on GitHub  ·  Interactive benchmark demo</a:t>
             </a:r>
           </a:p>
         </p:txBody>
@@ -7578,7 +7578,7 @@
               </a:defRPr>
             </a:pPr>
             <a:r>
-              <a:rPr sz="975">
+              <a:rPr sz="1000">
                 <a:solidFill>
                   <a:srgbClr val="C6C7C6"/>
                 </a:solidFill>
@@ -7761,7 +7761,7 @@
         </p:nvSpPr>
         <p:spPr>
           <a:xfrm xmlns:a="http://schemas.openxmlformats.org/drawingml/2006/main">
-            <a:off x="609600" y="2714625"/>
+            <a:off x="609600" y="2468880"/>
             <a:ext cx="10668000" cy="381000"/>
           </a:xfrm>
           <a:prstGeom xmlns:a="http://schemas.openxmlformats.org/drawingml/2006/main" prst="rect">
@@ -7917,7 +7917,7 @@
         </p:nvSpPr>
         <p:spPr>
           <a:xfrm xmlns:a="http://schemas.openxmlformats.org/drawingml/2006/main">
-            <a:off x="609600" y="3171825"/>
+            <a:off x="609600" y="2834640"/>
             <a:ext cx="10668000" cy="1381125"/>
           </a:xfrm>
           <a:prstGeom xmlns:a="http://schemas.openxmlformats.org/drawingml/2006/main" prst="rect">
@@ -8038,17 +8038,17 @@
                 <a:spcPct val="115000"/>
               </a:lnSpc>
               <a:spcAft>
-                <a:spcPts val="200"/>
+                <a:spcPts val="400"/>
               </a:spcAft>
             </a:pPr>
             <a:r>
-              <a:rPr sz="1300" b="0">
+              <a:rPr sz="1600" b="0">
                 <a:solidFill>
                   <a:srgbClr val="FFFFFF"/>
                 </a:solidFill>
                 <a:latin typeface="Arial"/>
               </a:rPr>
-              <a:t>Should we position the final artifact primarily as a defense mechanism (zero-latency line-rate runtime monitor beating external LLM guards) or as a mechanistic discovery paper (MoE routing bifurcation and executive subspace geometry)?</a:t>
+              <a:t>Should we position the final artifact primarily as a runtime defense mechanism (zero-latency monitor beating external LLM guards) or as a mechanistic discovery paper (latent executive subspace geometry)?</a:t>
             </a:r>
           </a:p>
         </p:txBody>
@@ -8069,7 +8069,7 @@
         </p:nvSpPr>
         <p:spPr>
           <a:xfrm xmlns:a="http://schemas.openxmlformats.org/drawingml/2006/main">
-            <a:off x="609600" y="3857625"/>
+            <a:off x="609600" y="3794760"/>
             <a:ext cx="10668000" cy="381000"/>
           </a:xfrm>
           <a:prstGeom xmlns:a="http://schemas.openxmlformats.org/drawingml/2006/main" prst="rect">
@@ -8225,7 +8225,7 @@
         </p:nvSpPr>
         <p:spPr>
           <a:xfrm xmlns:a="http://schemas.openxmlformats.org/drawingml/2006/main">
-            <a:off x="609600" y="4314825"/>
+            <a:off x="609600" y="4160520"/>
             <a:ext cx="10668000" cy="1381125"/>
           </a:xfrm>
           <a:prstGeom xmlns:a="http://schemas.openxmlformats.org/drawingml/2006/main" prst="rect">
@@ -8346,17 +8346,17 @@
                 <a:spcPct val="115000"/>
               </a:lnSpc>
               <a:spcAft>
-                <a:spcPts val="200"/>
+                <a:spcPts val="400"/>
               </a:spcAft>
             </a:pPr>
             <a:r>
-              <a:rPr sz="1300" b="0">
+              <a:rPr sz="1600" b="0">
                 <a:solidFill>
                   <a:srgbClr val="FFFFFF"/>
                 </a:solidFill>
                 <a:latin typeface="Arial"/>
               </a:rPr>
-              <a:t>What standard of causal evidence is most compelling to the AI alignment community: directional projection clamping, activation path patching, or end-to-end steering rollouts?</a:t>
+              <a:t>What standard of causal evidence is most compelling to the alignment community: directional clamping, activation path patching, or end-to-end steering rollouts?</a:t>
             </a:r>
           </a:p>
         </p:txBody>
@@ -8377,7 +8377,7 @@
         </p:nvSpPr>
         <p:spPr>
           <a:xfrm xmlns:a="http://schemas.openxmlformats.org/drawingml/2006/main">
-            <a:off x="609600" y="5000625"/>
+            <a:off x="609600" y="5120640"/>
             <a:ext cx="10668000" cy="381000"/>
           </a:xfrm>
           <a:prstGeom xmlns:a="http://schemas.openxmlformats.org/drawingml/2006/main" prst="rect">
@@ -8533,7 +8533,7 @@
         </p:nvSpPr>
         <p:spPr>
           <a:xfrm xmlns:a="http://schemas.openxmlformats.org/drawingml/2006/main">
-            <a:off x="609600" y="5457825"/>
+            <a:off x="609600" y="5486400"/>
             <a:ext cx="10668000" cy="1381125"/>
           </a:xfrm>
           <a:prstGeom xmlns:a="http://schemas.openxmlformats.org/drawingml/2006/main" prst="rect">
@@ -8654,17 +8654,17 @@
                 <a:spcPct val="115000"/>
               </a:lnSpc>
               <a:spcAft>
-                <a:spcPts val="200"/>
+                <a:spcPts val="400"/>
               </a:spcAft>
             </a:pPr>
             <a:r>
-              <a:rPr sz="1300" b="0">
+              <a:rPr sz="1600" b="0">
                 <a:solidFill>
                   <a:srgbClr val="FFFFFF"/>
                 </a:solidFill>
                 <a:latin typeface="Arial"/>
               </a:rPr>
-              <a:t>Access to multi-A100/H100 GPU compute nodes to extract layerwise activations and run causal interventions on 70B+ open models (Llama-3-70B, Qwen-2.5-72B) during Weeks 7–8.</a:t>
+              <a:t>Access to multi-GPU (A100/H100) compute nodes to extract layerwise activations and run causal interventions on 70B+ models (Llama-3-70B, Qwen-2.5-72B).</a:t>
             </a:r>
           </a:p>
         </p:txBody>
@@ -9147,7 +9147,7 @@
                 <a:spcPct val="115000"/>
               </a:lnSpc>
               <a:spcAft>
-                <a:spcPts val="300"/>
+                <a:spcPts val="400"/>
               </a:spcAft>
             </a:pPr>
             <a:r>
@@ -9305,9 +9305,9 @@
               </a:defRPr>
             </a:pPr>
             <a:r>
-              <a:rPr sz="975">
-                <a:solidFill>
-                  <a:srgbClr val="67758A"/>
+              <a:rPr sz="1000">
+                <a:solidFill>
+                  <a:srgbClr val="475569"/>
                 </a:solidFill>
                 <a:latin typeface="Courier New"/>
               </a:rPr>
@@ -9765,17 +9765,17 @@
                 <a:spcPct val="115000"/>
               </a:lnSpc>
               <a:spcAft>
-                <a:spcPts val="200"/>
+                <a:spcPts val="500"/>
               </a:spcAft>
             </a:pPr>
             <a:r>
-              <a:rPr sz="1080" b="0">
+              <a:rPr sz="1450" b="0">
                 <a:solidFill>
                   <a:srgbClr val="13294B"/>
                 </a:solidFill>
                 <a:latin typeface="Arial"/>
               </a:rPr>
-              <a:t>• Target Model: gpt-oss-20b (25 transformer layers, 32 MoE experts, top-4 routing, hidden dimension 2880).</a:t>
+              <a:t>• Model &amp; Harness: gpt-oss-20b (25 layers, 32 MoE experts, 2880 dim); bfloat16 forward pass with 93–100% rollout agreement.</a:t>
             </a:r>
           </a:p>
           <a:p xmlns:a="http://schemas.openxmlformats.org/drawingml/2006/main">
@@ -9784,36 +9784,17 @@
                 <a:spcPct val="115000"/>
               </a:lnSpc>
               <a:spcAft>
-                <a:spcPts val="200"/>
+                <a:spcPts val="500"/>
               </a:spcAft>
             </a:pPr>
             <a:r>
-              <a:rPr sz="1080" b="0">
+              <a:rPr sz="1450" b="0">
                 <a:solidFill>
                   <a:srgbClr val="13294B"/>
                 </a:solidFill>
                 <a:latin typeface="Arial"/>
               </a:rPr>
-              <a:t>• Inference Harness: Decoupled HuggingFace bfloat16 forward pass (interp/gptoss.py) matching vLLM chat rollout token IDs with 93–100% agreement.</a:t>
-            </a:r>
-          </a:p>
-          <a:p xmlns:a="http://schemas.openxmlformats.org/drawingml/2006/main">
-            <a:pPr>
-              <a:lnSpc>
-                <a:spcPct val="115000"/>
-              </a:lnSpc>
-              <a:spcAft>
-                <a:spcPts val="200"/>
-              </a:spcAft>
-            </a:pPr>
-            <a:r>
-              <a:rPr sz="1080" b="0">
-                <a:solidFill>
-                  <a:srgbClr val="13294B"/>
-                </a:solidFill>
-                <a:latin typeface="Arial"/>
-              </a:rPr>
-              <a:t>• Probing Method: L2-regularized logistic regression on layerwise residual activations at memory_result_end, averaged across Layers 14–19.</a:t>
+              <a:t>• Linear Probing: L2 logistic probes on residual stream at memory_result_end, isolating executive Layers 14–19.</a:t>
             </a:r>
           </a:p>
         </p:txBody>
@@ -10111,17 +10092,17 @@
                 <a:spcPct val="115000"/>
               </a:lnSpc>
               <a:spcAft>
-                <a:spcPts val="200"/>
+                <a:spcPts val="500"/>
               </a:spcAft>
             </a:pPr>
             <a:r>
-              <a:rPr sz="1100" b="0">
+              <a:rPr sz="1450" b="0">
                 <a:solidFill>
                   <a:srgbClr val="13294B"/>
                 </a:solidFill>
                 <a:latin typeface="Arial"/>
               </a:rPr>
-              <a:t>• Codebase: github.com/RaghavAgarwal08/sleeper_detection (branch raghav/probe-live-inert).</a:t>
+              <a:t>• Open Codebase: github.com/RaghavAgarwal08/sleeper_detection (branch raghav/probe-live-inert).</a:t>
             </a:r>
           </a:p>
           <a:p xmlns:a="http://schemas.openxmlformats.org/drawingml/2006/main">
@@ -10130,36 +10111,17 @@
                 <a:spcPct val="115000"/>
               </a:lnSpc>
               <a:spcAft>
-                <a:spcPts val="200"/>
+                <a:spcPts val="500"/>
               </a:spcAft>
             </a:pPr>
             <a:r>
-              <a:rPr sz="1100" b="0">
+              <a:rPr sz="1450" b="0">
                 <a:solidFill>
                   <a:srgbClr val="13294B"/>
                 </a:solidFill>
                 <a:latin typeface="Arial"/>
               </a:rPr>
-              <a:t>• Evaluation Scripts: Fully reproducible via interp/probe_live_inert/jev_baseline.py and interp/detector_demo.py.</a:t>
-            </a:r>
-          </a:p>
-          <a:p xmlns:a="http://schemas.openxmlformats.org/drawingml/2006/main">
-            <a:pPr>
-              <a:lnSpc>
-                <a:spcPct val="115000"/>
-              </a:lnSpc>
-              <a:spcAft>
-                <a:spcPts val="200"/>
-              </a:spcAft>
-            </a:pPr>
-            <a:r>
-              <a:rPr sz="1100" b="0">
-                <a:solidFill>
-                  <a:srgbClr val="13294B"/>
-                </a:solidFill>
-                <a:latin typeface="Arial"/>
-              </a:rPr>
-              <a:t>• Artifacts: Benchmark logs, activation indices, and JSON reports cached in results/.</a:t>
+              <a:t>• Live Benchmark Site: https://pndh.github.io/sleeper_detection/ with interactive inspector &amp; artifacts.</a:t>
             </a:r>
           </a:p>
         </p:txBody>
@@ -10180,7 +10142,7 @@
         </p:nvSpPr>
         <p:spPr>
           <a:xfrm xmlns:a="http://schemas.openxmlformats.org/drawingml/2006/main">
-            <a:off x="609600" y="4810125"/>
+            <a:off x="609600" y="4846320"/>
             <a:ext cx="10477500" cy="285750"/>
           </a:xfrm>
           <a:prstGeom xmlns:a="http://schemas.openxmlformats.org/drawingml/2006/main" prst="rect">
@@ -10336,7 +10298,7 @@
         </p:nvSpPr>
         <p:spPr>
           <a:xfrm xmlns:a="http://schemas.openxmlformats.org/drawingml/2006/main">
-            <a:off x="609600" y="5257800"/>
+            <a:off x="609600" y="5212080"/>
             <a:ext cx="10763250" cy="619125"/>
           </a:xfrm>
           <a:prstGeom xmlns:a="http://schemas.openxmlformats.org/drawingml/2006/main" prst="rect">
@@ -10457,55 +10419,17 @@
                 <a:spcPct val="115000"/>
               </a:lnSpc>
               <a:spcAft>
-                <a:spcPts val="200"/>
+                <a:spcPts val="400"/>
               </a:spcAft>
             </a:pPr>
             <a:r>
-              <a:rPr sz="1150" b="0">
+              <a:rPr sz="1400" b="0">
                 <a:solidFill>
                   <a:srgbClr val="13294B"/>
                 </a:solidFill>
                 <a:latin typeface="Arial"/>
               </a:rPr>
-              <a:t>• Li et al. (2026), 'Sleeper Attacks on Autonomous LLM Agents via Persistent Memory'</a:t>
-            </a:r>
-          </a:p>
-          <a:p xmlns:a="http://schemas.openxmlformats.org/drawingml/2006/main">
-            <a:pPr>
-              <a:lnSpc>
-                <a:spcPct val="115000"/>
-              </a:lnSpc>
-              <a:spcAft>
-                <a:spcPts val="200"/>
-              </a:spcAft>
-            </a:pPr>
-            <a:r>
-              <a:rPr sz="1150" b="0">
-                <a:solidFill>
-                  <a:srgbClr val="13294B"/>
-                </a:solidFill>
-                <a:latin typeface="Arial"/>
-              </a:rPr>
-              <a:t>• Zou et al. (2023), 'Representation Engineering: A Top-Down Approach to AI Transparency'</a:t>
-            </a:r>
-          </a:p>
-          <a:p xmlns:a="http://schemas.openxmlformats.org/drawingml/2006/main">
-            <a:pPr>
-              <a:lnSpc>
-                <a:spcPct val="115000"/>
-              </a:lnSpc>
-              <a:spcAft>
-                <a:spcPts val="200"/>
-              </a:spcAft>
-            </a:pPr>
-            <a:r>
-              <a:rPr sz="1150" b="0">
-                <a:solidFill>
-                  <a:srgbClr val="13294B"/>
-                </a:solidFill>
-                <a:latin typeface="Arial"/>
-              </a:rPr>
-              <a:t>• TypeSafe Decisions API (~typesafe/jev-latest), OpenRouter Security Evaluation Benchmark</a:t>
+              <a:t>• Li et al. (2026), 'Sleeper Attacks on LLM Agents via Persistent Memory'  ·  Zou et al. (2023), 'Representation Engineering'  ·  TypeSafe Decisions API (~typesafe/jev-latest)</a:t>
             </a:r>
           </a:p>
         </p:txBody>
@@ -11150,9 +11074,9 @@
               </a:defRPr>
             </a:pPr>
             <a:r>
-              <a:rPr sz="975">
-                <a:solidFill>
-                  <a:srgbClr val="67758A"/>
+              <a:rPr sz="1000">
+                <a:solidFill>
+                  <a:srgbClr val="475569"/>
                 </a:solidFill>
                 <a:latin typeface="Courier New"/>
               </a:rPr>
@@ -11610,17 +11534,17 @@
                 <a:spcPct val="115000"/>
               </a:lnSpc>
               <a:spcAft>
-                <a:spcPts val="300"/>
+                <a:spcPts val="400"/>
               </a:spcAft>
             </a:pPr>
             <a:r>
-              <a:rPr sz="1500" b="0">
+              <a:rPr sz="1750" b="1">
                 <a:solidFill>
                   <a:srgbClr val="13294B"/>
                 </a:solidFill>
                 <a:latin typeface="Arial"/>
               </a:rPr>
-              <a:t>Can internal activation probing detect dormant sleeper instructions in an LLM agent's memory during benign turns, before action triggers fire?</a:t>
+              <a:t>Can internal activation probing detect dormant sleeper instructions in agent memory during benign turns, before triggers fire?</a:t>
             </a:r>
           </a:p>
         </p:txBody>
@@ -11918,17 +11842,36 @@
                 <a:spcPct val="115000"/>
               </a:lnSpc>
               <a:spcAft>
-                <a:spcPts val="300"/>
+                <a:spcPts val="600"/>
               </a:spcAft>
             </a:pPr>
             <a:r>
-              <a:rPr sz="1250" b="0">
+              <a:rPr sz="1500" b="0">
                 <a:solidFill>
                   <a:srgbClr val="13294B"/>
                 </a:solidFill>
                 <a:latin typeface="Arial"/>
               </a:rPr>
-              <a:t>Probing memory tokens (memory_result_end) yields an 8.02x stronger signal than prompt edges. Linear probes achieve 0.998–1.000 AUROC on live vs. inert instruction separation across held-out templates and domains, while frontier text guards (Jev) suffer heavy false alarms (TPR@5% FPR drops to 30%).</a:t>
+              <a:t>• 1.000 AUROC / 100% Recall: Separates pending instructions from inert records across held-out splits.</a:t>
+            </a:r>
+          </a:p>
+          <a:p xmlns:a="http://schemas.openxmlformats.org/drawingml/2006/main">
+            <a:pPr>
+              <a:lnSpc>
+                <a:spcPct val="115000"/>
+              </a:lnSpc>
+              <a:spcAft>
+                <a:spcPts val="600"/>
+              </a:spcAft>
+            </a:pPr>
+            <a:r>
+              <a:rPr sz="1500" b="0">
+                <a:solidFill>
+                  <a:srgbClr val="13294B"/>
+                </a:solidFill>
+                <a:latin typeface="Arial"/>
+              </a:rPr>
+              <a:t>• 8× Signal Amplification: Memory tokens carry 8.02× stronger signal than prompt boundary delimiters.</a:t>
             </a:r>
           </a:p>
         </p:txBody>
@@ -12226,17 +12169,36 @@
                 <a:spcPct val="115000"/>
               </a:lnSpc>
               <a:spcAft>
-                <a:spcPts val="300"/>
+                <a:spcPts val="500"/>
               </a:spcAft>
             </a:pPr>
             <a:r>
-              <a:rPr sz="1400" b="0">
+              <a:rPr sz="1550" b="0">
                 <a:solidFill>
                   <a:srgbClr val="13294B"/>
                 </a:solidFill>
                 <a:latin typeface="Arial"/>
               </a:rPr>
-              <a:t>Validate causal steering: execute activation patching and directional clamping on Layers 14–19 to prove probe features causally drive downstream sleeper execution rather than acting as passive correlates.</a:t>
+              <a:t>• Validate Causal Steering: Directional clamping on Layers 14–19 to prove features actively cause trigger execution.</a:t>
+            </a:r>
+          </a:p>
+          <a:p xmlns:a="http://schemas.openxmlformats.org/drawingml/2006/main">
+            <a:pPr>
+              <a:lnSpc>
+                <a:spcPct val="115000"/>
+              </a:lnSpc>
+              <a:spcAft>
+                <a:spcPts val="500"/>
+              </a:spcAft>
+            </a:pPr>
+            <a:r>
+              <a:rPr sz="1550" b="0">
+                <a:solidFill>
+                  <a:srgbClr val="13294B"/>
+                </a:solidFill>
+                <a:latin typeface="Arial"/>
+              </a:rPr>
+              <a:t>• Cross-Architecture Transfer: Replicate probe extraction on dense open models (Llama-3-70B).</a:t>
             </a:r>
           </a:p>
         </p:txBody>
@@ -12881,9 +12843,9 @@
               </a:defRPr>
             </a:pPr>
             <a:r>
-              <a:rPr sz="975">
-                <a:solidFill>
-                  <a:srgbClr val="67758A"/>
+              <a:rPr sz="1000">
+                <a:solidFill>
+                  <a:srgbClr val="475569"/>
                 </a:solidFill>
                 <a:latin typeface="Courier New"/>
               </a:rPr>
@@ -13341,17 +13303,36 @@
                 <a:spcPct val="115000"/>
               </a:lnSpc>
               <a:spcAft>
-                <a:spcPts val="200"/>
+                <a:spcPts val="500"/>
               </a:spcAft>
             </a:pPr>
             <a:r>
-              <a:rPr sz="1200" b="0">
+              <a:rPr sz="1450" b="0">
                 <a:solidFill>
                   <a:srgbClr val="13294B"/>
                 </a:solidFill>
                 <a:latin typeface="Arial"/>
               </a:rPr>
-              <a:t>Autonomous agents rely on persistent scratchpads, episodic memory, and tool logs. Attackers can plant dormant sleeper instructions that persist across benign turns and trigger only on specific future conditions. Textual guardrails face severe failure modes: they panic over benign technical keywords (50%+ false alarms) or miss disguised payloads (10% recall on realistic attacks).</a:t>
+              <a:t>• Persistent Memory Threat: Attackers plant sleeper notes in agent scratchpads that stay dormant until future triggers.</a:t>
+            </a:r>
+          </a:p>
+          <a:p xmlns:a="http://schemas.openxmlformats.org/drawingml/2006/main">
+            <a:pPr>
+              <a:lnSpc>
+                <a:spcPct val="115000"/>
+              </a:lnSpc>
+              <a:spcAft>
+                <a:spcPts val="500"/>
+              </a:spcAft>
+            </a:pPr>
+            <a:r>
+              <a:rPr sz="1450" b="0">
+                <a:solidFill>
+                  <a:srgbClr val="13294B"/>
+                </a:solidFill>
+                <a:latin typeface="Arial"/>
+              </a:rPr>
+              <a:t>• Text Guardrails Fail: External judges suffer 50%+ false alarms on code logs and miss disguised phrasing (10% recall).</a:t>
             </a:r>
           </a:p>
         </p:txBody>
@@ -13649,17 +13630,36 @@
                 <a:spcPct val="115000"/>
               </a:lnSpc>
               <a:spcAft>
-                <a:spcPts val="200"/>
+                <a:spcPts val="500"/>
               </a:spcAft>
             </a:pPr>
             <a:r>
-              <a:rPr sz="1250" b="0">
+              <a:rPr sz="1450" b="0">
                 <a:solidFill>
                   <a:srgbClr val="13294B"/>
                 </a:solidFill>
                 <a:latin typeface="Arial"/>
               </a:rPr>
-              <a:t>Can white-box mechanistic interpretability (residual stream probing at Layers 14–19 and MoE routing bifurcation at Layer 20) reliably detect dormant malicious memory state before token generation begins, robust to surface paraphrase and semantic disguise?</a:t>
+              <a:t>• Mechanistic Opportunity: Transformer self-attention binds active intent into executive subspaces (Layers 14–19) before token 1.</a:t>
+            </a:r>
+          </a:p>
+          <a:p xmlns:a="http://schemas.openxmlformats.org/drawingml/2006/main">
+            <a:pPr>
+              <a:lnSpc>
+                <a:spcPct val="115000"/>
+              </a:lnSpc>
+              <a:spcAft>
+                <a:spcPts val="500"/>
+              </a:spcAft>
+            </a:pPr>
+            <a:r>
+              <a:rPr sz="1450" b="0">
+                <a:solidFill>
+                  <a:srgbClr val="13294B"/>
+                </a:solidFill>
+                <a:latin typeface="Arial"/>
+              </a:rPr>
+              <a:t>• Surface Invariance: Internal latent representations bypass surface disguise and semantic camouflage.</a:t>
             </a:r>
           </a:p>
         </p:txBody>
@@ -13957,17 +13957,36 @@
                 <a:spcPct val="115000"/>
               </a:lnSpc>
               <a:spcAft>
-                <a:spcPts val="200"/>
+                <a:spcPts val="500"/>
               </a:spcAft>
             </a:pPr>
             <a:r>
-              <a:rPr sz="1300" b="0">
+              <a:rPr sz="1550" b="0">
                 <a:solidFill>
                   <a:srgbClr val="13294B"/>
                 </a:solidFill>
                 <a:latin typeface="Arial"/>
               </a:rPr>
-              <a:t>Provides proactive, zero-latency defense (&lt;0.1 ms on GPU VRAM) against sleeper agents and indirect prompt injections without waiting for catastrophic tool execution or relying on expensive, noisy external LLM judges.</a:t>
+              <a:t>• Zero-Latency Preemption: Scored in &lt; 0.1 ms on GPU VRAM at $0 token cost (vs 1,500 ms / 2x cost for external LLM judges).</a:t>
+            </a:r>
+          </a:p>
+          <a:p xmlns:a="http://schemas.openxmlformats.org/drawingml/2006/main">
+            <a:pPr>
+              <a:lnSpc>
+                <a:spcPct val="115000"/>
+              </a:lnSpc>
+              <a:spcAft>
+                <a:spcPts val="500"/>
+              </a:spcAft>
+            </a:pPr>
+            <a:r>
+              <a:rPr sz="1550" b="0">
+                <a:solidFill>
+                  <a:srgbClr val="13294B"/>
+                </a:solidFill>
+                <a:latin typeface="Arial"/>
+              </a:rPr>
+              <a:t>• In-Flight Intervention: Enables clamping sleeper vectors before catastrophic agent tool calls execute.</a:t>
             </a:r>
           </a:p>
         </p:txBody>
@@ -14612,9 +14631,9 @@
               </a:defRPr>
             </a:pPr>
             <a:r>
-              <a:rPr sz="975">
-                <a:solidFill>
-                  <a:srgbClr val="67758A"/>
+              <a:rPr sz="1000">
+                <a:solidFill>
+                  <a:srgbClr val="475569"/>
                 </a:solidFill>
                 <a:latin typeface="Courier New"/>
               </a:rPr>
@@ -15072,17 +15091,17 @@
                 <a:spcPct val="115000"/>
               </a:lnSpc>
               <a:spcAft>
-                <a:spcPts val="300"/>
+                <a:spcPts val="500"/>
               </a:spcAft>
             </a:pPr>
             <a:r>
-              <a:rPr sz="1150" b="0">
+              <a:rPr sz="1400" b="0">
                 <a:solidFill>
                   <a:srgbClr val="13294B"/>
                 </a:solidFill>
                 <a:latin typeface="Arial"/>
               </a:rPr>
-              <a:t>• Model: gpt-oss-20b (25-layer MoE, 32 experts, top-4 routing, 2880 residual dim).</a:t>
+              <a:t>• gpt-oss-20b: 25-layer MoE, 32 experts (2880 residual dim).</a:t>
             </a:r>
           </a:p>
           <a:p xmlns:a="http://schemas.openxmlformats.org/drawingml/2006/main">
@@ -15091,17 +15110,17 @@
                 <a:spcPct val="115000"/>
               </a:lnSpc>
               <a:spcAft>
-                <a:spcPts val="300"/>
+                <a:spcPts val="500"/>
               </a:spcAft>
             </a:pPr>
             <a:r>
-              <a:rPr sz="1150" b="0">
+              <a:rPr sz="1400" b="0">
                 <a:solidFill>
                   <a:srgbClr val="13294B"/>
                 </a:solidFill>
                 <a:latin typeface="Arial"/>
               </a:rPr>
-              <a:t>• Data: behavior_v1 multi-turn agent benchmark; paired 43-token control twins canceling 99.95% container overhead.</a:t>
+              <a:t>• behavior_v1: 1,924 trigger requests across 10 enterprise domains with 43-token paired twins canceling noise.</a:t>
             </a:r>
           </a:p>
         </p:txBody>
@@ -15399,17 +15418,17 @@
                 <a:spcPct val="115000"/>
               </a:lnSpc>
               <a:spcAft>
-                <a:spcPts val="300"/>
+                <a:spcPts val="500"/>
               </a:spcAft>
             </a:pPr>
             <a:r>
-              <a:rPr sz="1150" b="0">
+              <a:rPr sz="1400" b="0">
                 <a:solidFill>
                   <a:srgbClr val="13294B"/>
                 </a:solidFill>
                 <a:latin typeface="Arial"/>
               </a:rPr>
-              <a:t>• Decoupled bfloat16 forward pass extracting layerwise residual streams (h_L) and router logits (r_L).</a:t>
+              <a:t>• Residual Probing: Decoupled bfloat16 forward pass extracting Layers 0–24 at memory_result_end.</a:t>
             </a:r>
           </a:p>
           <a:p xmlns:a="http://schemas.openxmlformats.org/drawingml/2006/main">
@@ -15418,17 +15437,17 @@
                 <a:spcPct val="115000"/>
               </a:lnSpc>
               <a:spcAft>
-                <a:spcPts val="300"/>
+                <a:spcPts val="500"/>
               </a:spcAft>
             </a:pPr>
             <a:r>
-              <a:rPr sz="1150" b="0">
+              <a:rPr sz="1400" b="0">
                 <a:solidFill>
                   <a:srgbClr val="13294B"/>
                 </a:solidFill>
                 <a:latin typeface="Arial"/>
               </a:rPr>
-              <a:t>• Multi-position linear probing at memory_result_end vs prompt boundaries; leave-one-domain-out (LODO) CV.</a:t>
+              <a:t>• L2 Probing &amp; LODO: Leave-one-domain-out cross-validation testing true out-of-distribution transfer.</a:t>
             </a:r>
           </a:p>
         </p:txBody>
@@ -15726,17 +15745,17 @@
                 <a:spcPct val="115000"/>
               </a:lnSpc>
               <a:spcAft>
-                <a:spcPts val="300"/>
+                <a:spcPts val="500"/>
               </a:spcAft>
             </a:pPr>
             <a:r>
-              <a:rPr sz="1150" b="0">
+              <a:rPr sz="1400" b="0">
                 <a:solidFill>
                   <a:srgbClr val="13294B"/>
                 </a:solidFill>
                 <a:latin typeface="Arial"/>
               </a:rPr>
-              <a:t>• Primary Metrics: Out-of-fold AUROC across held-out phrasing templates (E1) and domains (E2).</a:t>
+              <a:t>• Out-of-Fold AUROC: Unseen templates (E1) &amp; domains (E2).</a:t>
             </a:r>
           </a:p>
           <a:p xmlns:a="http://schemas.openxmlformats.org/drawingml/2006/main">
@@ -15745,36 +15764,17 @@
                 <a:spcPct val="115000"/>
               </a:lnSpc>
               <a:spcAft>
-                <a:spcPts val="300"/>
+                <a:spcPts val="500"/>
               </a:spcAft>
             </a:pPr>
             <a:r>
-              <a:rPr sz="1150" b="0">
+              <a:rPr sz="1400" b="0">
                 <a:solidFill>
                   <a:srgbClr val="13294B"/>
                 </a:solidFill>
                 <a:latin typeface="Arial"/>
               </a:rPr>
-              <a:t>• Security SLA: True Positive Rate at 5% False Positive Rate (TPR@5% FPR).</a:t>
-            </a:r>
-          </a:p>
-          <a:p xmlns:a="http://schemas.openxmlformats.org/drawingml/2006/main">
-            <a:pPr>
-              <a:lnSpc>
-                <a:spcPct val="115000"/>
-              </a:lnSpc>
-              <a:spcAft>
-                <a:spcPts val="300"/>
-              </a:spcAft>
-            </a:pPr>
-            <a:r>
-              <a:rPr sz="1150" b="0">
-                <a:solidFill>
-                  <a:srgbClr val="13294B"/>
-                </a:solidFill>
-                <a:latin typeface="Arial"/>
-              </a:rPr>
-              <a:t>• MoE top-4 Jaccard routing overlap (J).</a:t>
+              <a:t>• Operational SLA: TPR @ 5% FPR, plus Execution Prediction AUROC (Will It Fire?).</a:t>
             </a:r>
           </a:p>
         </p:txBody>
@@ -16072,17 +16072,17 @@
                 <a:spcPct val="115000"/>
               </a:lnSpc>
               <a:spcAft>
-                <a:spcPts val="200"/>
+                <a:spcPts val="400"/>
               </a:spcAft>
             </a:pPr>
             <a:r>
-              <a:rPr sz="1250" b="0">
+              <a:rPr sz="1500" b="1">
                 <a:solidFill>
                   <a:srgbClr val="13294B"/>
                 </a:solidFill>
                 <a:latin typeface="Arial"/>
               </a:rPr>
-              <a:t>WORKING HYPOTHESIS: If an agent actively commits to an unexecuted instruction, internal self-attention will bind the payload into executive task-planning subspaces (Layers 14–19) prior to generation, yielding near-perfect linear separability from inert reference text regardless of lexical camouflage.</a:t>
+              <a:t>WORKING HYPOTHESIS: When an agent commits to an unexecuted instruction, self-attention binds it into executive task-planning subspaces (Layers 14–19), yielding linear separability before token 1 generates.</a:t>
             </a:r>
           </a:p>
         </p:txBody>
@@ -16727,9 +16727,9 @@
               </a:defRPr>
             </a:pPr>
             <a:r>
-              <a:rPr sz="975">
-                <a:solidFill>
-                  <a:srgbClr val="67758A"/>
+              <a:rPr sz="1000">
+                <a:solidFill>
+                  <a:srgbClr val="475569"/>
                 </a:solidFill>
                 <a:latin typeface="Courier New"/>
               </a:rPr>
@@ -16927,14 +16927,14 @@
                     <a:p>
                       <a:pPr>
                         <a:lnSpc>
-                          <a:spcPct val="110000"/>
+                          <a:spcPct val="115000"/>
                         </a:lnSpc>
                         <a:spcAft>
-                          <a:spcPts val="200"/>
+                          <a:spcPts val="300"/>
                         </a:spcAft>
                       </a:pPr>
                       <a:r>
-                        <a:rPr sz="1150" b="1">
+                        <a:rPr sz="1300" b="1">
                           <a:solidFill>
                             <a:srgbClr val="FFFFFF"/>
                           </a:solidFill>
@@ -16981,14 +16981,14 @@
                     <a:p>
                       <a:pPr>
                         <a:lnSpc>
-                          <a:spcPct val="110000"/>
+                          <a:spcPct val="115000"/>
                         </a:lnSpc>
                         <a:spcAft>
-                          <a:spcPts val="200"/>
+                          <a:spcPts val="300"/>
                         </a:spcAft>
                       </a:pPr>
                       <a:r>
-                        <a:rPr sz="1150" b="1">
+                        <a:rPr sz="1300" b="1">
                           <a:solidFill>
                             <a:srgbClr val="FFFFFF"/>
                           </a:solidFill>
@@ -17029,20 +17029,20 @@
                     <a:p>
                       <a:pPr>
                         <a:lnSpc>
-                          <a:spcPct val="110000"/>
+                          <a:spcPct val="115000"/>
                         </a:lnSpc>
                         <a:spcAft>
-                          <a:spcPts val="200"/>
+                          <a:spcPts val="300"/>
                         </a:spcAft>
                       </a:pPr>
                       <a:r>
-                        <a:rPr sz="1150" b="1">
+                        <a:rPr sz="1300" b="1">
                           <a:solidFill>
                             <a:srgbClr val="FFFFFF"/>
                           </a:solidFill>
                           <a:latin typeface="Arial"/>
                         </a:rPr>
-                        <a:t>Evidence / change</a:t>
+                        <a:t>Evidence / verified result</a:t>
                       </a:r>
                     </a:p>
                   </a:txBody>
@@ -17079,14 +17079,14 @@
                     <a:p>
                       <a:pPr>
                         <a:lnSpc>
-                          <a:spcPct val="110000"/>
+                          <a:spcPct val="115000"/>
                         </a:lnSpc>
                         <a:spcAft>
-                          <a:spcPts val="200"/>
+                          <a:spcPts val="300"/>
                         </a:spcAft>
                       </a:pPr>
                       <a:r>
-                        <a:rPr sz="1000" b="0">
+                        <a:rPr sz="1250" b="0">
                           <a:solidFill>
                             <a:srgbClr val="13294B"/>
                           </a:solidFill>
@@ -17127,14 +17127,14 @@
                     <a:p>
                       <a:pPr>
                         <a:lnSpc>
-                          <a:spcPct val="110000"/>
+                          <a:spcPct val="115000"/>
                         </a:lnSpc>
                         <a:spcAft>
-                          <a:spcPts val="200"/>
+                          <a:spcPts val="300"/>
                         </a:spcAft>
                       </a:pPr>
                       <a:r>
-                        <a:rPr sz="1000" b="1">
+                        <a:rPr sz="1250" b="1">
                           <a:solidFill>
                             <a:srgbClr val="13294B"/>
                           </a:solidFill>
@@ -17169,14 +17169,14 @@
                     <a:p>
                       <a:pPr>
                         <a:lnSpc>
-                          <a:spcPct val="110000"/>
+                          <a:spcPct val="115000"/>
                         </a:lnSpc>
                         <a:spcAft>
-                          <a:spcPts val="200"/>
+                          <a:spcPts val="300"/>
                         </a:spcAft>
                       </a:pPr>
                       <a:r>
-                        <a:rPr sz="1000" b="0">
+                        <a:rPr sz="1250" b="0">
                           <a:solidFill>
                             <a:srgbClr val="13294B"/>
                           </a:solidFill>
@@ -17213,14 +17213,14 @@
                     <a:p>
                       <a:pPr>
                         <a:lnSpc>
-                          <a:spcPct val="110000"/>
+                          <a:spcPct val="115000"/>
                         </a:lnSpc>
                         <a:spcAft>
-                          <a:spcPts val="200"/>
+                          <a:spcPts val="300"/>
                         </a:spcAft>
                       </a:pPr>
                       <a:r>
-                        <a:rPr sz="1000" b="0">
+                        <a:rPr sz="1250" b="0">
                           <a:solidFill>
                             <a:srgbClr val="13294B"/>
                           </a:solidFill>
@@ -17261,14 +17261,14 @@
                     <a:p>
                       <a:pPr>
                         <a:lnSpc>
-                          <a:spcPct val="110000"/>
+                          <a:spcPct val="115000"/>
                         </a:lnSpc>
                         <a:spcAft>
-                          <a:spcPts val="200"/>
+                          <a:spcPts val="300"/>
                         </a:spcAft>
                       </a:pPr>
                       <a:r>
-                        <a:rPr sz="1000" b="1">
+                        <a:rPr sz="1250" b="1">
                           <a:solidFill>
                             <a:srgbClr val="13294B"/>
                           </a:solidFill>
@@ -17303,20 +17303,20 @@
                     <a:p>
                       <a:pPr>
                         <a:lnSpc>
-                          <a:spcPct val="110000"/>
+                          <a:spcPct val="115000"/>
                         </a:lnSpc>
                         <a:spcAft>
-                          <a:spcPts val="200"/>
+                          <a:spcPts val="300"/>
                         </a:spcAft>
                       </a:pPr>
                       <a:r>
-                        <a:rPr sz="1000" b="0">
+                        <a:rPr sz="1250" b="0">
                           <a:solidFill>
                             <a:srgbClr val="13294B"/>
                           </a:solidFill>
                           <a:latin typeface="Arial"/>
                         </a:rPr>
-                        <a:t>Identified delimiter collapse at prompt edge; discovered 8.02x signal boost at memory tokens; isolated Layers 14–19 as primary subspace (0.998–1.000 AUROC).</a:t>
+                        <a:t>Identified 8× signal boost at memory tokens; isolated Layers 14–19 as primary planning subspace (1.000 AUROC on E1 &amp; E2).</a:t>
                       </a:r>
                     </a:p>
                   </a:txBody>
@@ -17347,20 +17347,20 @@
                     <a:p>
                       <a:pPr>
                         <a:lnSpc>
-                          <a:spcPct val="110000"/>
+                          <a:spcPct val="115000"/>
                         </a:lnSpc>
                         <a:spcAft>
-                          <a:spcPts val="200"/>
+                          <a:spcPts val="300"/>
                         </a:spcAft>
                       </a:pPr>
                       <a:r>
-                        <a:rPr sz="1000" b="0">
+                        <a:rPr sz="1250" b="0">
                           <a:solidFill>
                             <a:srgbClr val="13294B"/>
                           </a:solidFill>
                           <a:latin typeface="Arial"/>
                         </a:rPr>
-                        <a:t>Frontier Guard Baseline &amp; Realism Ladder</a:t>
+                        <a:t>Frontier Guard Benchmark &amp; Realism Ladder</a:t>
                       </a:r>
                     </a:p>
                   </a:txBody>
@@ -17395,14 +17395,14 @@
                     <a:p>
                       <a:pPr>
                         <a:lnSpc>
-                          <a:spcPct val="110000"/>
+                          <a:spcPct val="115000"/>
                         </a:lnSpc>
                         <a:spcAft>
-                          <a:spcPts val="200"/>
+                          <a:spcPts val="300"/>
                         </a:spcAft>
                       </a:pPr>
                       <a:r>
-                        <a:rPr sz="1000" b="1">
+                        <a:rPr sz="1250" b="1">
                           <a:solidFill>
                             <a:srgbClr val="13294B"/>
                           </a:solidFill>
@@ -17437,20 +17437,20 @@
                     <a:p>
                       <a:pPr>
                         <a:lnSpc>
-                          <a:spcPct val="110000"/>
+                          <a:spcPct val="115000"/>
                         </a:lnSpc>
                         <a:spcAft>
-                          <a:spcPts val="200"/>
+                          <a:spcPts val="300"/>
                         </a:spcAft>
                       </a:pPr>
                       <a:r>
-                        <a:rPr sz="1000" b="0">
+                        <a:rPr sz="1250" b="0">
                           <a:solidFill>
                             <a:srgbClr val="13294B"/>
                           </a:solidFill>
                           <a:latin typeface="Arial"/>
                         </a:rPr>
-                        <a:t>Integrated TypeSafe Jev with Context baseline; benchmarked Realism Ladder (L0–L4), demonstrating text judge collapse on disguised attacks.</a:t>
+                        <a:t>Benchmarked TypeSafe Jev (30% recall @ 5% FPR); proved text judges collapse to 10% recall on disguised attacks (L4).</a:t>
                       </a:r>
                     </a:p>
                   </a:txBody>
@@ -17614,17 +17614,17 @@
                 <a:spcPct val="115000"/>
               </a:lnSpc>
               <a:spcAft>
-                <a:spcPts val="200"/>
+                <a:spcPts val="300"/>
               </a:spcAft>
             </a:pPr>
             <a:r>
-              <a:rPr sz="1350" b="0">
+              <a:rPr sz="1500" b="1">
                 <a:solidFill>
                   <a:srgbClr val="13294B"/>
                 </a:solidFill>
                 <a:latin typeface="Arial"/>
               </a:rPr>
-              <a:t>PLAN UPDATE  /  Expanded scope from pure activation extraction to direct head-to-head benchmarking against frontier guard models (Jev) and semantic disguise to prove operational defense superiority.</a:t>
+              <a:t>PLAN UPDATE  /  Expanded scope from pure activation extraction to head-to-head benchmarking against frontier guard models (Jev) and semantic camouflage, proving operational defense superiority.</a:t>
             </a:r>
           </a:p>
         </p:txBody>
@@ -18269,9 +18269,9 @@
               </a:defRPr>
             </a:pPr>
             <a:r>
-              <a:rPr sz="975">
-                <a:solidFill>
-                  <a:srgbClr val="67758A"/>
+              <a:rPr sz="1000">
+                <a:solidFill>
+                  <a:srgbClr val="475569"/>
                 </a:solidFill>
                 <a:latin typeface="Courier New"/>
               </a:rPr>
@@ -18468,14 +18468,14 @@
                     <a:p>
                       <a:pPr>
                         <a:lnSpc>
-                          <a:spcPct val="110000"/>
+                          <a:spcPct val="115000"/>
                         </a:lnSpc>
                         <a:spcAft>
-                          <a:spcPts val="200"/>
+                          <a:spcPts val="300"/>
                         </a:spcAft>
                       </a:pPr>
                       <a:r>
-                        <a:rPr sz="1150" b="1">
+                        <a:rPr sz="1300" b="1">
                           <a:solidFill>
                             <a:srgbClr val="FFFFFF"/>
                           </a:solidFill>
@@ -18522,20 +18522,20 @@
                     <a:p>
                       <a:pPr>
                         <a:lnSpc>
-                          <a:spcPct val="110000"/>
+                          <a:spcPct val="115000"/>
                         </a:lnSpc>
                         <a:spcAft>
-                          <a:spcPts val="200"/>
+                          <a:spcPts val="300"/>
                         </a:spcAft>
                       </a:pPr>
                       <a:r>
-                        <a:rPr sz="1150" b="1">
+                        <a:rPr sz="1300" b="1">
                           <a:solidFill>
                             <a:srgbClr val="FFFFFF"/>
                           </a:solidFill>
                           <a:latin typeface="Arial"/>
                         </a:rPr>
-                        <a:t>Current setup</a:t>
+                        <a:t>Current benchmark setup (behavior_v1)</a:t>
                       </a:r>
                     </a:p>
                   </a:txBody>
@@ -18572,20 +18572,20 @@
                     <a:p>
                       <a:pPr>
                         <a:lnSpc>
-                          <a:spcPct val="110000"/>
+                          <a:spcPct val="115000"/>
                         </a:lnSpc>
                         <a:spcAft>
-                          <a:spcPts val="200"/>
+                          <a:spcPts val="300"/>
                         </a:spcAft>
                       </a:pPr>
                       <a:r>
-                        <a:rPr sz="1000" b="0">
+                        <a:rPr sz="1200" b="0">
                           <a:solidFill>
                             <a:srgbClr val="13294B"/>
                           </a:solidFill>
                           <a:latin typeface="Arial"/>
                         </a:rPr>
-                        <a:t>Data / coverage</a:t>
+                        <a:t>Data &amp; Coverage</a:t>
                       </a:r>
                     </a:p>
                   </a:txBody>
@@ -18620,20 +18620,20 @@
                     <a:p>
                       <a:pPr>
                         <a:lnSpc>
-                          <a:spcPct val="110000"/>
+                          <a:spcPct val="115000"/>
                         </a:lnSpc>
                         <a:spcAft>
-                          <a:spcPts val="200"/>
+                          <a:spcPts val="300"/>
                         </a:spcAft>
                       </a:pPr>
                       <a:r>
-                        <a:rPr sz="1000" b="0">
+                        <a:rPr sz="1200" b="0">
                           <a:solidFill>
                             <a:srgbClr val="13294B"/>
                           </a:solidFill>
                           <a:latin typeface="Arial"/>
                         </a:rPr>
-                        <a:t>behavior_v1 multi-turn agent traces; sound 2x2 factorial dataset (Live/Inert x Malicious/Benign) across 10 enterprise domains; Realism Ladder L0–L4.</a:t>
+                        <a:t>behavior_v1: 1,924 agent interactions across 10 enterprise domains (Shopify, Slack, HubSpot, etc.); 6 live &amp; 6 inert templates; Realism Ladder L0–L4.</a:t>
                       </a:r>
                     </a:p>
                   </a:txBody>
@@ -18664,20 +18664,20 @@
                     <a:p>
                       <a:pPr>
                         <a:lnSpc>
-                          <a:spcPct val="110000"/>
+                          <a:spcPct val="115000"/>
                         </a:lnSpc>
                         <a:spcAft>
-                          <a:spcPts val="200"/>
+                          <a:spcPts val="300"/>
                         </a:spcAft>
                       </a:pPr>
                       <a:r>
-                        <a:rPr sz="1000" b="0">
+                        <a:rPr sz="1200" b="0">
                           <a:solidFill>
                             <a:srgbClr val="13294B"/>
                           </a:solidFill>
                           <a:latin typeface="Arial"/>
                         </a:rPr>
-                        <a:t>Splits / generalization</a:t>
+                        <a:t>Generalization Splits</a:t>
                       </a:r>
                     </a:p>
                   </a:txBody>
@@ -18712,20 +18712,20 @@
                     <a:p>
                       <a:pPr>
                         <a:lnSpc>
-                          <a:spcPct val="110000"/>
+                          <a:spcPct val="115000"/>
                         </a:lnSpc>
                         <a:spcAft>
-                          <a:spcPts val="200"/>
+                          <a:spcPts val="300"/>
                         </a:spcAft>
                       </a:pPr>
                       <a:r>
-                        <a:rPr sz="1000" b="0">
+                        <a:rPr sz="1200" b="0">
                           <a:solidFill>
                             <a:srgbClr val="13294B"/>
                           </a:solidFill>
                           <a:latin typeface="Arial"/>
                         </a:rPr>
-                        <a:t>Held-out evaluation across 3 splits: E1 (unseen instruction phrasing, n=40), E2 (unseen environment domains, n=40), E3 (jointly unseen templates &amp; domains, n=40).</a:t>
+                        <a:t>Held-out evaluation across 3 splits: E1 (unseen instruction phrasing), E2 (unseen enterprise domains), E3 (jointly unseen templates &amp; domains).</a:t>
                       </a:r>
                     </a:p>
                   </a:txBody>
@@ -18756,20 +18756,20 @@
                     <a:p>
                       <a:pPr>
                         <a:lnSpc>
-                          <a:spcPct val="110000"/>
+                          <a:spcPct val="115000"/>
                         </a:lnSpc>
                         <a:spcAft>
-                          <a:spcPts val="200"/>
+                          <a:spcPts val="300"/>
                         </a:spcAft>
                       </a:pPr>
                       <a:r>
-                        <a:rPr sz="1000" b="0">
+                        <a:rPr sz="1200" b="0">
                           <a:solidFill>
                             <a:srgbClr val="13294B"/>
                           </a:solidFill>
                           <a:latin typeface="Arial"/>
                         </a:rPr>
-                        <a:t>Baselines / controls</a:t>
+                        <a:t>Baselines &amp; Controls</a:t>
                       </a:r>
                     </a:p>
                   </a:txBody>
@@ -18804,20 +18804,20 @@
                     <a:p>
                       <a:pPr>
                         <a:lnSpc>
-                          <a:spcPct val="110000"/>
+                          <a:spcPct val="115000"/>
                         </a:lnSpc>
                         <a:spcAft>
-                          <a:spcPts val="200"/>
+                          <a:spcPts val="300"/>
                         </a:spcAft>
                       </a:pPr>
                       <a:r>
-                        <a:rPr sz="1000" b="0">
+                        <a:rPr sz="1200" b="0">
                           <a:solidFill>
                             <a:srgbClr val="13294B"/>
                           </a:solidFill>
                           <a:latin typeface="Arial"/>
                         </a:rPr>
-                        <a:t>Paired control twins (format control); TF-IDF n-gram logistic regression; prompt-length baseline; TypeSafe Jev Decisions API with full security policy context.</a:t>
+                        <a:t>Paired control twins (format control); TF-IDF n-gram text baselines; prompt length; TypeSafe Jev Decisions API with enterprise policy.</a:t>
                       </a:r>
                     </a:p>
                   </a:txBody>
@@ -18848,20 +18848,20 @@
                     <a:p>
                       <a:pPr>
                         <a:lnSpc>
-                          <a:spcPct val="110000"/>
+                          <a:spcPct val="115000"/>
                         </a:lnSpc>
                         <a:spcAft>
-                          <a:spcPts val="200"/>
+                          <a:spcPts val="300"/>
                         </a:spcAft>
                       </a:pPr>
                       <a:r>
-                        <a:rPr sz="1000" b="0">
+                        <a:rPr sz="1200" b="0">
                           <a:solidFill>
                             <a:srgbClr val="13294B"/>
                           </a:solidFill>
                           <a:latin typeface="Arial"/>
                         </a:rPr>
-                        <a:t>Metrics / uncertainty</a:t>
+                        <a:t>Metrics &amp; SLA</a:t>
                       </a:r>
                     </a:p>
                   </a:txBody>
@@ -18896,20 +18896,20 @@
                     <a:p>
                       <a:pPr>
                         <a:lnSpc>
-                          <a:spcPct val="110000"/>
+                          <a:spcPct val="115000"/>
                         </a:lnSpc>
                         <a:spcAft>
-                          <a:spcPts val="200"/>
+                          <a:spcPts val="300"/>
                         </a:spcAft>
                       </a:pPr>
                       <a:r>
-                        <a:rPr sz="1000" b="0">
+                        <a:rPr sz="1200" b="0">
                           <a:solidFill>
                             <a:srgbClr val="13294B"/>
                           </a:solidFill>
                           <a:latin typeface="Arial"/>
                         </a:rPr>
-                        <a:t>Out-of-fold AUROC with 95% bootstrap CIs; TPR @ 5% False Positive Rate SLA; two-sided t-tests on factorial interaction; MoE top-4 Jaccard routing similarity.</a:t>
+                        <a:t>Out-of-fold AUROC with 95% bootstrap CIs; TPR @ 5% False Positive Rate SLA; per-layer residual curve (Layers 0–24); execution prediction AUROC.</a:t>
                       </a:r>
                     </a:p>
                   </a:txBody>
@@ -19414,17 +19414,17 @@
                 <a:spcPct val="115000"/>
               </a:lnSpc>
               <a:spcAft>
-                <a:spcPts val="200"/>
+                <a:spcPts val="400"/>
               </a:spcAft>
             </a:pPr>
             <a:r>
-              <a:rPr sz="2400" b="1">
+              <a:rPr sz="2300" b="1">
                 <a:solidFill>
                   <a:srgbClr val="13294B"/>
                 </a:solidFill>
                 <a:latin typeface="Arial"/>
               </a:rPr>
-              <a:t>Probes Achieve 1.00 AUROC Across Phrasing &amp; Disguise, Outperforming Text Guards</a:t>
+              <a:t>Internal Probes Achieve 1.00 AUROC Across Unseen Phrasing, While Text Guards Collapse</a:t>
             </a:r>
           </a:p>
         </p:txBody>
@@ -19572,9 +19572,9 @@
               </a:defRPr>
             </a:pPr>
             <a:r>
-              <a:rPr sz="975">
-                <a:solidFill>
-                  <a:srgbClr val="67758A"/>
+              <a:rPr sz="1000">
+                <a:solidFill>
+                  <a:srgbClr val="475569"/>
                 </a:solidFill>
                 <a:latin typeface="Courier New"/>
               </a:rPr>
@@ -20045,7 +20045,7 @@
         </p:nvSpPr>
         <p:spPr>
           <a:xfrm xmlns:a="http://schemas.openxmlformats.org/drawingml/2006/main">
-            <a:off x="8239125" y="2667000"/>
+            <a:off x="8239125" y="2606040"/>
             <a:ext cx="3333750" cy="381000"/>
           </a:xfrm>
           <a:prstGeom xmlns:a="http://schemas.openxmlformats.org/drawingml/2006/main" prst="rect">
@@ -20201,7 +20201,7 @@
         </p:nvSpPr>
         <p:spPr>
           <a:xfrm xmlns:a="http://schemas.openxmlformats.org/drawingml/2006/main">
-            <a:off x="8239125" y="3124200"/>
+            <a:off x="8239125" y="2926080"/>
             <a:ext cx="3333750" cy="1381125"/>
           </a:xfrm>
           <a:prstGeom xmlns:a="http://schemas.openxmlformats.org/drawingml/2006/main" prst="rect">
@@ -20319,58 +20319,39 @@
           <a:p xmlns:a="http://schemas.openxmlformats.org/drawingml/2006/main">
             <a:pPr>
               <a:lnSpc>
-                <a:spcPct val="110000"/>
+                <a:spcPct val="115000"/>
               </a:lnSpc>
               <a:spcAft>
-                <a:spcPts val="300"/>
+                <a:spcPts val="400"/>
               </a:spcAft>
             </a:pPr>
             <a:r>
-              <a:rPr sz="950" b="0">
+              <a:rPr sz="1300" b="0">
                 <a:solidFill>
                   <a:srgbClr val="13294B"/>
                 </a:solidFill>
                 <a:latin typeface="Arial"/>
               </a:rPr>
-              <a:t>• Internal linear probes (Layers 14–19) achieve 0.998–1.000 AUROC across all held-out splits (E1–E3) with 100% TPR @ 5% FPR.</a:t>
+              <a:t>• 1.000 AUROC / 100% TPR: Generalizes across held-out phrasing (E1) and domains (E2).</a:t>
             </a:r>
           </a:p>
           <a:p xmlns:a="http://schemas.openxmlformats.org/drawingml/2006/main">
             <a:pPr>
               <a:lnSpc>
-                <a:spcPct val="110000"/>
+                <a:spcPct val="115000"/>
               </a:lnSpc>
               <a:spcAft>
-                <a:spcPts val="300"/>
+                <a:spcPts val="400"/>
               </a:spcAft>
             </a:pPr>
             <a:r>
-              <a:rPr sz="950" b="0">
+              <a:rPr sz="1300" b="0">
                 <a:solidFill>
                   <a:srgbClr val="13294B"/>
                 </a:solidFill>
                 <a:latin typeface="Arial"/>
               </a:rPr>
-              <a:t>• Delimiter tokens collapse signal (0.0036 cos dist), whereas internal memory tokens amplify it 8.02x (0.0288).</a:t>
-            </a:r>
-          </a:p>
-          <a:p xmlns:a="http://schemas.openxmlformats.org/drawingml/2006/main">
-            <a:pPr>
-              <a:lnSpc>
-                <a:spcPct val="110000"/>
-              </a:lnSpc>
-              <a:spcAft>
-                <a:spcPts val="300"/>
-              </a:spcAft>
-            </a:pPr>
-            <a:r>
-              <a:rPr sz="950" b="0">
-                <a:solidFill>
-                  <a:srgbClr val="13294B"/>
-                </a:solidFill>
-                <a:latin typeface="Arial"/>
-              </a:rPr>
-              <a:t>• Frontier text guards (Jev) drop to 0.816 AUROC (30% TPR @ 5% FPR), while disguised attacks (L2–L4) collapse text recall to 10–20%.</a:t>
+              <a:t>• 0.945 Execution AUROC: Probes know if a note will fire before token 1 generates.</a:t>
             </a:r>
           </a:p>
         </p:txBody>
@@ -20391,7 +20372,7 @@
         </p:nvSpPr>
         <p:spPr>
           <a:xfrm xmlns:a="http://schemas.openxmlformats.org/drawingml/2006/main">
-            <a:off x="8239125" y="4429125"/>
+            <a:off x="8239125" y="4160520"/>
             <a:ext cx="3333750" cy="381000"/>
           </a:xfrm>
           <a:prstGeom xmlns:a="http://schemas.openxmlformats.org/drawingml/2006/main" prst="rect">
@@ -20547,7 +20528,7 @@
         </p:nvSpPr>
         <p:spPr>
           <a:xfrm xmlns:a="http://schemas.openxmlformats.org/drawingml/2006/main">
-            <a:off x="8239125" y="4886325"/>
+            <a:off x="8239125" y="4480560"/>
             <a:ext cx="3333750" cy="1381125"/>
           </a:xfrm>
           <a:prstGeom xmlns:a="http://schemas.openxmlformats.org/drawingml/2006/main" prst="rect">
@@ -20665,39 +20646,39 @@
           <a:p xmlns:a="http://schemas.openxmlformats.org/drawingml/2006/main">
             <a:pPr>
               <a:lnSpc>
-                <a:spcPct val="110000"/>
+                <a:spcPct val="115000"/>
               </a:lnSpc>
               <a:spcAft>
-                <a:spcPts val="300"/>
+                <a:spcPts val="400"/>
               </a:spcAft>
             </a:pPr>
             <a:r>
-              <a:rPr sz="980" b="0">
+              <a:rPr sz="1300" b="0">
                 <a:solidFill>
                   <a:srgbClr val="13294B"/>
                 </a:solidFill>
                 <a:latin typeface="Arial"/>
               </a:rPr>
-              <a:t>• Self-attention binds active instructions into executive task-planning subspaces prior to token generation, while treating inert logs as passive context.</a:t>
+              <a:t>• Latent Commitment: Transformer binds active intent into Layers 14–19 while treating inert logs as passive context.</a:t>
             </a:r>
           </a:p>
           <a:p xmlns:a="http://schemas.openxmlformats.org/drawingml/2006/main">
             <a:pPr>
               <a:lnSpc>
-                <a:spcPct val="110000"/>
+                <a:spcPct val="115000"/>
               </a:lnSpc>
               <a:spcAft>
-                <a:spcPts val="300"/>
+                <a:spcPts val="400"/>
               </a:spcAft>
             </a:pPr>
             <a:r>
-              <a:rPr sz="980" b="0">
+              <a:rPr sz="1300" b="0">
                 <a:solidFill>
                   <a:srgbClr val="13294B"/>
                 </a:solidFill>
                 <a:latin typeface="Arial"/>
               </a:rPr>
-              <a:t>• External text models evaluate surface words and fail on semantic camouflage, whereas internal probes read the model's decoded intent with zero added latency (&lt;0.1 ms on GPU VRAM).</a:t>
+              <a:t>• Surface Invariance: Probes score in &lt;0.1 ms; Jev drops to 30% TPR and text guards fail on disguise.</a:t>
             </a:r>
           </a:p>
         </p:txBody>
@@ -20719,7 +20700,7 @@
         <p:spPr>
           <a:xfrm>
             <a:off x="612648" y="3017520"/>
-            <a:ext cx="7315200" cy="3145536"/>
+            <a:ext cx="7315200" cy="3246120"/>
           </a:xfrm>
           <a:prstGeom prst="rect">
             <a:avLst/>
@@ -21366,9 +21347,9 @@
               </a:defRPr>
             </a:pPr>
             <a:r>
-              <a:rPr sz="975">
-                <a:solidFill>
-                  <a:srgbClr val="67758A"/>
+              <a:rPr sz="1000">
+                <a:solidFill>
+                  <a:srgbClr val="475569"/>
                 </a:solidFill>
                 <a:latin typeface="Courier New"/>
               </a:rPr>
@@ -21566,14 +21547,14 @@
                     <a:p>
                       <a:pPr>
                         <a:lnSpc>
-                          <a:spcPct val="110000"/>
+                          <a:spcPct val="115000"/>
                         </a:lnSpc>
                         <a:spcAft>
-                          <a:spcPts val="200"/>
+                          <a:spcPts val="300"/>
                         </a:spcAft>
                       </a:pPr>
                       <a:r>
-                        <a:rPr sz="1150" b="1">
+                        <a:rPr sz="1300" b="1">
                           <a:solidFill>
                             <a:srgbClr val="FFFFFF"/>
                           </a:solidFill>
@@ -21620,14 +21601,14 @@
                     <a:p>
                       <a:pPr>
                         <a:lnSpc>
-                          <a:spcPct val="110000"/>
+                          <a:spcPct val="115000"/>
                         </a:lnSpc>
                         <a:spcAft>
-                          <a:spcPts val="200"/>
+                          <a:spcPts val="300"/>
                         </a:spcAft>
                       </a:pPr>
                       <a:r>
-                        <a:rPr sz="1150" b="1">
+                        <a:rPr sz="1300" b="1">
                           <a:solidFill>
                             <a:srgbClr val="FFFFFF"/>
                           </a:solidFill>
@@ -21668,14 +21649,14 @@
                     <a:p>
                       <a:pPr>
                         <a:lnSpc>
-                          <a:spcPct val="110000"/>
+                          <a:spcPct val="115000"/>
                         </a:lnSpc>
                         <a:spcAft>
-                          <a:spcPts val="200"/>
+                          <a:spcPts val="300"/>
                         </a:spcAft>
                       </a:pPr>
                       <a:r>
-                        <a:rPr sz="1150" b="1">
+                        <a:rPr sz="1300" b="1">
                           <a:solidFill>
                             <a:srgbClr val="FFFFFF"/>
                           </a:solidFill>
@@ -21718,20 +21699,20 @@
                     <a:p>
                       <a:pPr>
                         <a:lnSpc>
-                          <a:spcPct val="110000"/>
+                          <a:spcPct val="115000"/>
                         </a:lnSpc>
                         <a:spcAft>
-                          <a:spcPts val="200"/>
+                          <a:spcPts val="300"/>
                         </a:spcAft>
                       </a:pPr>
                       <a:r>
-                        <a:rPr sz="980" b="0">
+                        <a:rPr sz="1200" b="0">
                           <a:solidFill>
                             <a:srgbClr val="13294B"/>
                           </a:solidFill>
                           <a:latin typeface="Arial"/>
                         </a:rPr>
-                        <a:t>Baseline comparison</a:t>
+                        <a:t>Baseline Comparison</a:t>
                       </a:r>
                     </a:p>
                   </a:txBody>
@@ -21766,20 +21747,20 @@
                     <a:p>
                       <a:pPr>
                         <a:lnSpc>
-                          <a:spcPct val="110000"/>
+                          <a:spcPct val="115000"/>
                         </a:lnSpc>
                         <a:spcAft>
-                          <a:spcPts val="200"/>
+                          <a:spcPts val="300"/>
                         </a:spcAft>
                       </a:pPr>
                       <a:r>
-                        <a:rPr sz="980" b="0">
+                        <a:rPr sz="1200" b="0">
                           <a:solidFill>
                             <a:srgbClr val="13294B"/>
                           </a:solidFill>
                           <a:latin typeface="Arial"/>
                         </a:rPr>
-                        <a:t>Probe (1.000 AUROC / 100% TPR@5%FPR) decisively beats Jev (0.816 AUROC / 30% TPR@5%FPR) and prompt length (0.59 AUROC).</a:t>
+                        <a:t>Probe (1.000 AUROC, 100% TPR@5%FPR) decisively beats Jev (0.816 AUROC, 30% TPR) and prompt length (0.59).</a:t>
                       </a:r>
                     </a:p>
                   </a:txBody>
@@ -21808,20 +21789,20 @@
                     <a:p>
                       <a:pPr>
                         <a:lnSpc>
-                          <a:spcPct val="110000"/>
+                          <a:spcPct val="115000"/>
                         </a:lnSpc>
                         <a:spcAft>
-                          <a:spcPts val="200"/>
+                          <a:spcPts val="300"/>
                         </a:spcAft>
                       </a:pPr>
                       <a:r>
-                        <a:rPr sz="980" b="0">
+                        <a:rPr sz="1200" b="0">
                           <a:solidFill>
                             <a:srgbClr val="13294B"/>
                           </a:solidFill>
                           <a:latin typeface="Arial"/>
                         </a:rPr>
-                        <a:t>Benchmark LLaMA-Guard-3 and GPT-4o-mini judges under identical policy context.</a:t>
+                        <a:t>Benchmark LLaMA-Guard-3 and GPT-4o-mini under identical policy context.</a:t>
                       </a:r>
                     </a:p>
                   </a:txBody>
@@ -21852,20 +21833,20 @@
                     <a:p>
                       <a:pPr>
                         <a:lnSpc>
-                          <a:spcPct val="110000"/>
+                          <a:spcPct val="115000"/>
                         </a:lnSpc>
                         <a:spcAft>
-                          <a:spcPts val="200"/>
+                          <a:spcPts val="300"/>
                         </a:spcAft>
                       </a:pPr>
                       <a:r>
-                        <a:rPr sz="980" b="0">
+                        <a:rPr sz="1200" b="0">
                           <a:solidFill>
                             <a:srgbClr val="13294B"/>
                           </a:solidFill>
                           <a:latin typeface="Arial"/>
                         </a:rPr>
-                        <a:t>Ablation / control</a:t>
+                        <a:t>Ablation &amp; Control</a:t>
                       </a:r>
                     </a:p>
                   </a:txBody>
@@ -21900,20 +21881,20 @@
                     <a:p>
                       <a:pPr>
                         <a:lnSpc>
-                          <a:spcPct val="110000"/>
+                          <a:spcPct val="115000"/>
                         </a:lnSpc>
                         <a:spcAft>
-                          <a:spcPts val="200"/>
+                          <a:spcPts val="300"/>
                         </a:spcAft>
                       </a:pPr>
                       <a:r>
-                        <a:rPr sz="980" b="0">
+                        <a:rPr sz="1200" b="0">
                           <a:solidFill>
                             <a:srgbClr val="13294B"/>
                           </a:solidFill>
                           <a:latin typeface="Arial"/>
                         </a:rPr>
-                        <a:t>Paired twins eliminate 99.95% container overhead; delimiter collapse shows probe requires internal token coordinates (memory_result_end).</a:t>
+                        <a:t>Paired twins eliminate 99.95% container overhead; memory token yields 8× signal boost over prompt delimiter.</a:t>
                       </a:r>
                     </a:p>
                   </a:txBody>
@@ -21942,20 +21923,20 @@
                     <a:p>
                       <a:pPr>
                         <a:lnSpc>
-                          <a:spcPct val="110000"/>
+                          <a:spcPct val="115000"/>
                         </a:lnSpc>
                         <a:spcAft>
-                          <a:spcPts val="200"/>
+                          <a:spcPts val="300"/>
                         </a:spcAft>
                       </a:pPr>
                       <a:r>
-                        <a:rPr sz="980" b="0">
+                        <a:rPr sz="1200" b="0">
                           <a:solidFill>
                             <a:srgbClr val="13294B"/>
                           </a:solidFill>
                           <a:latin typeface="Arial"/>
                         </a:rPr>
-                        <a:t>Attention head ablation: patch individual heads in Layers 14–19 to isolate routing circuits.</a:t>
+                        <a:t>Attention head ablation: patch individual heads in Layers 14–19 to isolate causal circuits.</a:t>
                       </a:r>
                     </a:p>
                   </a:txBody>
@@ -21986,14 +21967,14 @@
                     <a:p>
                       <a:pPr>
                         <a:lnSpc>
-                          <a:spcPct val="110000"/>
+                          <a:spcPct val="115000"/>
                         </a:lnSpc>
                         <a:spcAft>
-                          <a:spcPts val="200"/>
+                          <a:spcPts val="300"/>
                         </a:spcAft>
                       </a:pPr>
                       <a:r>
-                        <a:rPr sz="980" b="0">
+                        <a:rPr sz="1200" b="0">
                           <a:solidFill>
                             <a:srgbClr val="13294B"/>
                           </a:solidFill>
@@ -22034,20 +22015,20 @@
                     <a:p>
                       <a:pPr>
                         <a:lnSpc>
-                          <a:spcPct val="110000"/>
+                          <a:spcPct val="115000"/>
                         </a:lnSpc>
                         <a:spcAft>
-                          <a:spcPts val="200"/>
+                          <a:spcPts val="300"/>
                         </a:spcAft>
                       </a:pPr>
                       <a:r>
-                        <a:rPr sz="980" b="0">
+                        <a:rPr sz="1200" b="0">
                           <a:solidFill>
                             <a:srgbClr val="13294B"/>
                           </a:solidFill>
                           <a:latin typeface="Arial"/>
                         </a:rPr>
-                        <a:t>Zero degradation on unseen phrasing templates (E1: 1.000 AUROC) and unseen enterprise domains (E2: 1.000 AUROC).</a:t>
+                        <a:t>Zero degradation on unseen phrasing (E1: 1.000) and unseen enterprise domains (E2: 1.000).</a:t>
                       </a:r>
                     </a:p>
                   </a:txBody>
@@ -22076,14 +22057,14 @@
                     <a:p>
                       <a:pPr>
                         <a:lnSpc>
-                          <a:spcPct val="110000"/>
+                          <a:spcPct val="115000"/>
                         </a:lnSpc>
                         <a:spcAft>
-                          <a:spcPts val="200"/>
+                          <a:spcPts val="300"/>
                         </a:spcAft>
                       </a:pPr>
                       <a:r>
-                        <a:rPr sz="980" b="0">
+                        <a:rPr sz="1200" b="0">
                           <a:solidFill>
                             <a:srgbClr val="13294B"/>
                           </a:solidFill>
@@ -22253,17 +22234,17 @@
                 <a:spcPct val="115000"/>
               </a:lnSpc>
               <a:spcAft>
-                <a:spcPts val="200"/>
+                <a:spcPts val="300"/>
               </a:spcAft>
             </a:pPr>
             <a:r>
-              <a:rPr sz="1350" b="0">
+              <a:rPr sz="1500" b="1">
                 <a:solidFill>
                   <a:srgbClr val="13294B"/>
                 </a:solidFill>
                 <a:latin typeface="Arial"/>
               </a:rPr>
-              <a:t>CONFIDENCE  /  High confidence that latent states linearly separate live instructions from inert logs in gpt-oss-20b; currently validating probe invariance across complex multi-step conversational history.</a:t>
+              <a:t>CONFIDENCE  /  High confidence that latent states linearly separate live instructions in gpt-oss-20b; currently verifying causal steering invariance across multi-turn history.</a:t>
             </a:r>
           </a:p>
         </p:txBody>
@@ -22908,9 +22889,9 @@
               </a:defRPr>
             </a:pPr>
             <a:r>
-              <a:rPr sz="975">
-                <a:solidFill>
-                  <a:srgbClr val="67758A"/>
+              <a:rPr sz="1000">
+                <a:solidFill>
+                  <a:srgbClr val="475569"/>
                 </a:solidFill>
                 <a:latin typeface="Courier New"/>
               </a:rPr>
@@ -23368,17 +23349,17 @@
                 <a:spcPct val="115000"/>
               </a:lnSpc>
               <a:spcAft>
-                <a:spcPts val="200"/>
+                <a:spcPts val="600"/>
               </a:spcAft>
             </a:pPr>
             <a:r>
-              <a:rPr sz="1150" b="0">
+              <a:rPr sz="1500" b="0">
                 <a:solidFill>
                   <a:srgbClr val="13294B"/>
                 </a:solidFill>
                 <a:latin typeface="Arial"/>
               </a:rPr>
-              <a:t>• Architecture breadth: Probing has been validated primarily on gpt-oss-20b MoE; dense models (e.g. Llama-3-8B/70B) may distribute instruction representations across different layer depths.</a:t>
+              <a:t>• Architecture Breadth: Validated on gpt-oss-20b MoE; dense models (Llama-3-70B) may distribute planning across different depths.</a:t>
             </a:r>
           </a:p>
           <a:p xmlns:a="http://schemas.openxmlformats.org/drawingml/2006/main">
@@ -23387,17 +23368,17 @@
                 <a:spcPct val="115000"/>
               </a:lnSpc>
               <a:spcAft>
-                <a:spcPts val="200"/>
+                <a:spcPts val="600"/>
               </a:spcAft>
             </a:pPr>
             <a:r>
-              <a:rPr sz="1150" b="0">
+              <a:rPr sz="1500" b="0">
                 <a:solidFill>
                   <a:srgbClr val="13294B"/>
                 </a:solidFill>
                 <a:latin typeface="Arial"/>
               </a:rPr>
-              <a:t>• Dataset diversity: behavior_v1 evaluates structured agent tool calls; free-form multi-agent dialogues and long-context RAG scratchpads remain to be benchmarked.</a:t>
+              <a:t>• Interaction Scope: behavior_v1 tests single-tool triggers; multi-agent dialogues and long-context RAG remain to be tested.</a:t>
             </a:r>
           </a:p>
         </p:txBody>
@@ -23695,17 +23676,17 @@
                 <a:spcPct val="115000"/>
               </a:lnSpc>
               <a:spcAft>
-                <a:spcPts val="200"/>
+                <a:spcPts val="600"/>
               </a:spcAft>
             </a:pPr>
             <a:r>
-              <a:rPr sz="1150" b="0">
+              <a:rPr sz="1500" b="0">
                 <a:solidFill>
                   <a:srgbClr val="13294B"/>
                 </a:solidFill>
                 <a:latin typeface="Arial"/>
               </a:rPr>
-              <a:t>• Causal verification gap: Distinguishing whether probe directions actively cause trigger execution or merely correlate with prompt formatting.</a:t>
+              <a:t>• Causal Gap: Proving probe features actively cause trigger execution rather than merely correlating with memory structure.</a:t>
             </a:r>
           </a:p>
           <a:p xmlns:a="http://schemas.openxmlformats.org/drawingml/2006/main">
@@ -23714,17 +23695,17 @@
                 <a:spcPct val="115000"/>
               </a:lnSpc>
               <a:spcAft>
-                <a:spcPts val="200"/>
+                <a:spcPts val="600"/>
               </a:spcAft>
             </a:pPr>
             <a:r>
-              <a:rPr sz="1150" b="0">
+              <a:rPr sz="1500" b="0">
                 <a:solidFill>
                   <a:srgbClr val="13294B"/>
                 </a:solidFill>
                 <a:latin typeface="Arial"/>
               </a:rPr>
-              <a:t>• Mitigation: Implement causal intervention hooks (activation patching and directional steering) to demonstrate bidirectional control over sleeper execution.</a:t>
+              <a:t>• Mitigation: Implement directional steering and activation patching on Layers 14–19 during rollouts.</a:t>
             </a:r>
           </a:p>
         </p:txBody>
@@ -23866,17 +23847,17 @@
                 <a:spcPct val="115000"/>
               </a:lnSpc>
               <a:spcAft>
-                <a:spcPts val="200"/>
+                <a:spcPts val="300"/>
               </a:spcAft>
             </a:pPr>
             <a:r>
-              <a:rPr sz="1350" b="0">
+              <a:rPr sz="1550" b="1">
                 <a:solidFill>
                   <a:srgbClr val="13294B"/>
                 </a:solidFill>
                 <a:latin typeface="Arial"/>
               </a:rPr>
-              <a:t>SCOPE DECISION  /  Keep causal steering and cross-model validation as top priorities; drop further expansion of synthetic domain templates in favor of realistic enterprise agent workflows.</a:t>
+              <a:t>SCOPE DECISION  /  Prioritize causal steering and cross-model validation (Llama-3-70B) over expanding synthetic domain templates.</a:t>
             </a:r>
           </a:p>
         </p:txBody>

</xml_diff>

<commit_message>
feat(slides): add raghava7@illinois.edu contact and save as AIA Presentation slides.pptx
</commit_message>
<xml_diff>
--- a/AIA_Illinois_Midpoint_Checkpoint_Raghav_Agarwal.pptx
+++ b/AIA_Illinois_Midpoint_Checkpoint_Raghav_Agarwal.pptx
@@ -5372,7 +5372,7 @@
                 </a:solidFill>
                 <a:latin typeface="Arial"/>
               </a:rPr>
-              <a:t>Raghav Agarwal  ·  AIA Research Fellow</a:t>
+              <a:t>Raghav Agarwal (raghava7@illinois.edu)  ·  AIA Research Fellow</a:t>
             </a:r>
           </a:p>
           <a:p xmlns:a="http://schemas.openxmlformats.org/drawingml/2006/main">
@@ -10092,11 +10092,11 @@
                 <a:spcPct val="115000"/>
               </a:lnSpc>
               <a:spcAft>
-                <a:spcPts val="500"/>
+                <a:spcPts val="400"/>
               </a:spcAft>
             </a:pPr>
             <a:r>
-              <a:rPr sz="1450" b="0">
+              <a:rPr sz="1350" b="0">
                 <a:solidFill>
                   <a:srgbClr val="13294B"/>
                 </a:solidFill>
@@ -10111,17 +10111,36 @@
                 <a:spcPct val="115000"/>
               </a:lnSpc>
               <a:spcAft>
-                <a:spcPts val="500"/>
+                <a:spcPts val="400"/>
               </a:spcAft>
             </a:pPr>
             <a:r>
-              <a:rPr sz="1450" b="0">
+              <a:rPr sz="1350" b="0">
                 <a:solidFill>
                   <a:srgbClr val="13294B"/>
                 </a:solidFill>
                 <a:latin typeface="Arial"/>
               </a:rPr>
-              <a:t>• Live Benchmark Site: https://pndh.github.io/sleeper_detection/ with interactive inspector &amp; artifacts.</a:t>
+              <a:t>• Live Benchmark Site: https://pndh.github.io/sleeper_detection/</a:t>
+            </a:r>
+          </a:p>
+          <a:p xmlns:a="http://schemas.openxmlformats.org/drawingml/2006/main">
+            <a:pPr>
+              <a:lnSpc>
+                <a:spcPct val="115000"/>
+              </a:lnSpc>
+              <a:spcAft>
+                <a:spcPts val="400"/>
+              </a:spcAft>
+            </a:pPr>
+            <a:r>
+              <a:rPr sz="1350" b="0">
+                <a:solidFill>
+                  <a:srgbClr val="13294B"/>
+                </a:solidFill>
+                <a:latin typeface="Arial"/>
+              </a:rPr>
+              <a:t>• Contact / Inquiries: Raghav Agarwal · raghava7@illinois.edu</a:t>
             </a:r>
           </a:p>
         </p:txBody>

</xml_diff>